<commit_message>
Show both side faces in the front view
The back edge now rises and *splays outward* about the centre line, so
each layer is a symmetric truncated wedge and the left and right side
faces fall outside the front face.  Both are seen, equally, and both carry
the same shade so neither reads as the lit side.

The two alternatives do not work.  Shearing the back to one side, which is
what this view did before, hides the other side completely.  Narrowing the
back hides both, since the side faces then fall inside the front
silhouette -- which is simply what a box looks like from dead centre, its
sides exactly edge-on.  Widening is the only way to see both from a
straight-on view.

Co-Authored-By: Claude Opus 5 <noreply@anthropic.com>
Claude-Session: https://claude.ai/code/session_014A61zHZtLZU5uPXAWC8gtS
</commit_message>
<xml_diff>
--- a/figures/device_stack_electrode_front.pptx
+++ b/figures/device_stack_electrode_front.pptx
@@ -3090,7 +3090,141 @@
       <p:grpSpPr/>
       <p:sp>
         <p:nvSpPr>
-          <p:cNvPr id="2" name="Bottom-emitting OLED / Glass (n = 1.77) front"/>
+          <p:cNvPr id="2" name="Bottom-emitting OLED / Glass (n = 1.77) left"/>
+          <p:cNvSpPr/>
+          <p:nvPr/>
+        </p:nvSpPr>
+        <p:spPr>
+          <a:xfrm>
+            <a:off x="3992780" y="3781689"/>
+            <a:ext cx="274313" cy="574751"/>
+          </a:xfrm>
+          <a:custGeom>
+            <a:avLst/>
+            <a:gdLst/>
+            <a:ahLst/>
+            <a:cxnLst/>
+            <a:rect l="l" t="t" r="r" b="b"/>
+            <a:pathLst>
+              <a:path w="274313" h="574751">
+                <a:moveTo>
+                  <a:pt x="274313" y="574751"/>
+                </a:moveTo>
+                <a:lnTo>
+                  <a:pt x="0" y="400584"/>
+                </a:lnTo>
+                <a:lnTo>
+                  <a:pt x="0" y="0"/>
+                </a:lnTo>
+                <a:lnTo>
+                  <a:pt x="274313" y="174167"/>
+                </a:lnTo>
+                <a:close/>
+              </a:path>
+            </a:pathLst>
+          </a:custGeom>
+          <a:solidFill>
+            <a:srgbClr val="AEC0CE"/>
+          </a:solidFill>
+          <a:ln w="9525">
+            <a:solidFill>
+              <a:srgbClr val="5D666F"/>
+            </a:solidFill>
+          </a:ln>
+          <a:effectLst/>
+        </p:spPr>
+        <p:style>
+          <a:lnRef idx="1">
+            <a:schemeClr val="accent1"/>
+          </a:lnRef>
+          <a:fillRef idx="3">
+            <a:schemeClr val="accent1"/>
+          </a:fillRef>
+          <a:effectRef idx="2">
+            <a:schemeClr val="accent1"/>
+          </a:effectRef>
+          <a:fontRef idx="minor">
+            <a:schemeClr val="lt1"/>
+          </a:fontRef>
+        </p:style>
+        <p:txBody>
+          <a:bodyPr rtlCol="0" anchor="ctr"/>
+          <a:lstStyle/>
+          <a:p>
+            <a:pPr algn="ctr"/>
+          </a:p>
+        </p:txBody>
+      </p:sp>
+      <p:sp>
+        <p:nvSpPr>
+          <p:cNvPr id="3" name="Bottom-emitting OLED / Glass (n = 1.77) right"/>
+          <p:cNvSpPr/>
+          <p:nvPr/>
+        </p:nvSpPr>
+        <p:spPr>
+          <a:xfrm>
+            <a:off x="7924602" y="3781689"/>
+            <a:ext cx="274313" cy="574751"/>
+          </a:xfrm>
+          <a:custGeom>
+            <a:avLst/>
+            <a:gdLst/>
+            <a:ahLst/>
+            <a:cxnLst/>
+            <a:rect l="l" t="t" r="r" b="b"/>
+            <a:pathLst>
+              <a:path w="274313" h="574751">
+                <a:moveTo>
+                  <a:pt x="0" y="574751"/>
+                </a:moveTo>
+                <a:lnTo>
+                  <a:pt x="274313" y="400584"/>
+                </a:lnTo>
+                <a:lnTo>
+                  <a:pt x="274313" y="0"/>
+                </a:lnTo>
+                <a:lnTo>
+                  <a:pt x="0" y="174167"/>
+                </a:lnTo>
+                <a:close/>
+              </a:path>
+            </a:pathLst>
+          </a:custGeom>
+          <a:solidFill>
+            <a:srgbClr val="AEC0CE"/>
+          </a:solidFill>
+          <a:ln w="9525">
+            <a:solidFill>
+              <a:srgbClr val="5D666F"/>
+            </a:solidFill>
+          </a:ln>
+          <a:effectLst/>
+        </p:spPr>
+        <p:style>
+          <a:lnRef idx="1">
+            <a:schemeClr val="accent1"/>
+          </a:lnRef>
+          <a:fillRef idx="3">
+            <a:schemeClr val="accent1"/>
+          </a:fillRef>
+          <a:effectRef idx="2">
+            <a:schemeClr val="accent1"/>
+          </a:effectRef>
+          <a:fontRef idx="minor">
+            <a:schemeClr val="lt1"/>
+          </a:fontRef>
+        </p:style>
+        <p:txBody>
+          <a:bodyPr rtlCol="0" anchor="ctr"/>
+          <a:lstStyle/>
+          <a:p>
+            <a:pPr algn="ctr"/>
+          </a:p>
+        </p:txBody>
+      </p:sp>
+      <p:sp>
+        <p:nvSpPr>
+          <p:cNvPr id="4" name="Bottom-emitting OLED / Glass (n = 1.77) front"/>
           <p:cNvSpPr/>
           <p:nvPr/>
         </p:nvSpPr>
@@ -3157,14 +3291,49 @@
       </p:sp>
       <p:sp>
         <p:nvSpPr>
-          <p:cNvPr id="3" name="Bottom-emitting OLED / Glass (n = 1.77) side"/>
+          <p:cNvPr id="5" name="Bottom-emitting OLED / Glass (n = 1.77) label"/>
+          <p:cNvSpPr txBox="1"/>
+          <p:nvPr/>
+        </p:nvSpPr>
+        <p:spPr>
+          <a:xfrm>
+            <a:off x="4336760" y="3991996"/>
+            <a:ext cx="3518175" cy="328305"/>
+          </a:xfrm>
+          <a:prstGeom prst="rect">
+            <a:avLst/>
+          </a:prstGeom>
+          <a:noFill/>
+        </p:spPr>
+        <p:txBody>
+          <a:bodyPr wrap="square" anchor="ctr" lIns="0" rIns="0" tIns="0" bIns="0">
+            <a:noAutofit/>
+          </a:bodyPr>
+          <a:lstStyle/>
+          <a:p>
+            <a:pPr algn="ctr"/>
+            <a:r>
+              <a:rPr sz="994" b="0">
+                <a:solidFill>
+                  <a:srgbClr val="1B2026"/>
+                </a:solidFill>
+                <a:latin typeface="Arial"/>
+              </a:rPr>
+              <a:t>Glass (n = 1.77)</a:t>
+            </a:r>
+          </a:p>
+        </p:txBody>
+      </p:sp>
+      <p:sp>
+        <p:nvSpPr>
+          <p:cNvPr id="6" name="Bottom-emitting OLED / Transparent electrode left"/>
           <p:cNvSpPr/>
           <p:nvPr/>
         </p:nvSpPr>
         <p:spPr>
           <a:xfrm>
-            <a:off x="7924602" y="3781689"/>
-            <a:ext cx="278667" cy="574751"/>
+            <a:off x="3992780" y="3346271"/>
+            <a:ext cx="274313" cy="609585"/>
           </a:xfrm>
           <a:custGeom>
             <a:avLst/>
@@ -3173,25 +3342,25 @@
             <a:cxnLst/>
             <a:rect l="l" t="t" r="r" b="b"/>
             <a:pathLst>
-              <a:path w="278667" h="574751">
+              <a:path w="274313" h="609585">
                 <a:moveTo>
-                  <a:pt x="0" y="574751"/>
+                  <a:pt x="274313" y="609585"/>
                 </a:moveTo>
                 <a:lnTo>
-                  <a:pt x="278667" y="400584"/>
-                </a:lnTo>
-                <a:lnTo>
-                  <a:pt x="278667" y="0"/>
-                </a:lnTo>
-                <a:lnTo>
-                  <a:pt x="0" y="174167"/>
+                  <a:pt x="0" y="435418"/>
+                </a:lnTo>
+                <a:lnTo>
+                  <a:pt x="0" y="0"/>
+                </a:lnTo>
+                <a:lnTo>
+                  <a:pt x="274313" y="174167"/>
                 </a:lnTo>
                 <a:close/>
               </a:path>
             </a:pathLst>
           </a:custGeom>
           <a:solidFill>
-            <a:srgbClr val="A1B2BF"/>
+            <a:srgbClr val="6BB1C3"/>
           </a:solidFill>
           <a:ln w="9525">
             <a:solidFill>
@@ -3224,42 +3393,74 @@
       </p:sp>
       <p:sp>
         <p:nvSpPr>
-          <p:cNvPr id="4" name="Bottom-emitting OLED / Glass (n = 1.77) label"/>
-          <p:cNvSpPr txBox="1"/>
+          <p:cNvPr id="7" name="Bottom-emitting OLED / Transparent electrode right"/>
+          <p:cNvSpPr/>
           <p:nvPr/>
         </p:nvSpPr>
         <p:spPr>
           <a:xfrm>
-            <a:off x="4336760" y="3991996"/>
-            <a:ext cx="3518175" cy="328305"/>
-          </a:xfrm>
-          <a:prstGeom prst="rect">
+            <a:off x="7924602" y="3346271"/>
+            <a:ext cx="274313" cy="609585"/>
+          </a:xfrm>
+          <a:custGeom>
             <a:avLst/>
-          </a:prstGeom>
-          <a:noFill/>
-        </p:spPr>
-        <p:txBody>
-          <a:bodyPr wrap="square" anchor="ctr" lIns="0" rIns="0" tIns="0" bIns="0">
-            <a:noAutofit/>
-          </a:bodyPr>
+            <a:gdLst/>
+            <a:ahLst/>
+            <a:cxnLst/>
+            <a:rect l="l" t="t" r="r" b="b"/>
+            <a:pathLst>
+              <a:path w="274313" h="609585">
+                <a:moveTo>
+                  <a:pt x="0" y="609585"/>
+                </a:moveTo>
+                <a:lnTo>
+                  <a:pt x="274313" y="435418"/>
+                </a:lnTo>
+                <a:lnTo>
+                  <a:pt x="274313" y="0"/>
+                </a:lnTo>
+                <a:lnTo>
+                  <a:pt x="0" y="174167"/>
+                </a:lnTo>
+                <a:close/>
+              </a:path>
+            </a:pathLst>
+          </a:custGeom>
+          <a:solidFill>
+            <a:srgbClr val="6BB1C3"/>
+          </a:solidFill>
+          <a:ln w="9525">
+            <a:solidFill>
+              <a:srgbClr val="5D666F"/>
+            </a:solidFill>
+          </a:ln>
+          <a:effectLst/>
+        </p:spPr>
+        <p:style>
+          <a:lnRef idx="1">
+            <a:schemeClr val="accent1"/>
+          </a:lnRef>
+          <a:fillRef idx="3">
+            <a:schemeClr val="accent1"/>
+          </a:fillRef>
+          <a:effectRef idx="2">
+            <a:schemeClr val="accent1"/>
+          </a:effectRef>
+          <a:fontRef idx="minor">
+            <a:schemeClr val="lt1"/>
+          </a:fontRef>
+        </p:style>
+        <p:txBody>
+          <a:bodyPr rtlCol="0" anchor="ctr"/>
           <a:lstStyle/>
           <a:p>
             <a:pPr algn="ctr"/>
-            <a:r>
-              <a:rPr sz="994" b="0">
-                <a:solidFill>
-                  <a:srgbClr val="1B2026"/>
-                </a:solidFill>
-                <a:latin typeface="Arial"/>
-              </a:rPr>
-              <a:t>Glass (n = 1.77)</a:t>
-            </a:r>
-          </a:p>
-        </p:txBody>
-      </p:sp>
-      <p:sp>
-        <p:nvSpPr>
-          <p:cNvPr id="5" name="Bottom-emitting OLED / Transparent electrode front"/>
+          </a:p>
+        </p:txBody>
+      </p:sp>
+      <p:sp>
+        <p:nvSpPr>
+          <p:cNvPr id="8" name="Bottom-emitting OLED / Transparent electrode front"/>
           <p:cNvSpPr/>
           <p:nvPr/>
         </p:nvSpPr>
@@ -3326,14 +3527,84 @@
       </p:sp>
       <p:sp>
         <p:nvSpPr>
-          <p:cNvPr id="6" name="Bottom-emitting OLED / Transparent electrode side"/>
+          <p:cNvPr id="9" name="Bottom-emitting OLED / Transparent electrode label"/>
+          <p:cNvSpPr txBox="1"/>
+          <p:nvPr/>
+        </p:nvSpPr>
+        <p:spPr>
+          <a:xfrm>
+            <a:off x="4336760" y="3478203"/>
+            <a:ext cx="3518175" cy="328305"/>
+          </a:xfrm>
+          <a:prstGeom prst="rect">
+            <a:avLst/>
+          </a:prstGeom>
+          <a:noFill/>
+        </p:spPr>
+        <p:txBody>
+          <a:bodyPr wrap="square" anchor="ctr" lIns="0" rIns="0" tIns="0" bIns="0">
+            <a:noAutofit/>
+          </a:bodyPr>
+          <a:lstStyle/>
+          <a:p>
+            <a:pPr algn="ctr"/>
+            <a:r>
+              <a:rPr sz="994" b="0">
+                <a:solidFill>
+                  <a:srgbClr val="1B2026"/>
+                </a:solidFill>
+                <a:latin typeface="Arial"/>
+              </a:rPr>
+              <a:t>Transparent electrode</a:t>
+            </a:r>
+          </a:p>
+        </p:txBody>
+      </p:sp>
+      <p:sp>
+        <p:nvSpPr>
+          <p:cNvPr id="10" name="Bottom-emitting OLED / Transparent electrode label note"/>
+          <p:cNvSpPr txBox="1"/>
+          <p:nvPr/>
+        </p:nvSpPr>
+        <p:spPr>
+          <a:xfrm>
+            <a:off x="4336760" y="3703749"/>
+            <a:ext cx="3518175" cy="260380"/>
+          </a:xfrm>
+          <a:prstGeom prst="rect">
+            <a:avLst/>
+          </a:prstGeom>
+          <a:noFill/>
+        </p:spPr>
+        <p:txBody>
+          <a:bodyPr wrap="square" anchor="ctr" lIns="0" rIns="0" tIns="0" bIns="0">
+            <a:noAutofit/>
+          </a:bodyPr>
+          <a:lstStyle/>
+          <a:p>
+            <a:pPr algn="ctr"/>
+            <a:r>
+              <a:rPr sz="788" b="0">
+                <a:solidFill>
+                  <a:srgbClr val="D62828"/>
+                </a:solidFill>
+                <a:latin typeface="Arial"/>
+              </a:rPr>
+              <a:t>ITO 50 nm   or   Ag 10 nm</a:t>
+            </a:r>
+          </a:p>
+        </p:txBody>
+      </p:sp>
+      <p:sp>
+        <p:nvSpPr>
+          <p:cNvPr id="11" name="Bottom-emitting OLED / HTL (200 nm) left"/>
           <p:cNvSpPr/>
           <p:nvPr/>
         </p:nvSpPr>
         <p:spPr>
           <a:xfrm>
-            <a:off x="7924602" y="3346271"/>
-            <a:ext cx="278667" cy="609585"/>
+            <a:off x="3992780" y="2997937"/>
+            <a:ext cx="274313" cy="522501"/>
           </a:xfrm>
           <a:custGeom>
             <a:avLst/>
@@ -3342,25 +3613,25 @@
             <a:cxnLst/>
             <a:rect l="l" t="t" r="r" b="b"/>
             <a:pathLst>
-              <a:path w="278667" h="609585">
+              <a:path w="274313" h="522501">
                 <a:moveTo>
-                  <a:pt x="0" y="609585"/>
+                  <a:pt x="274313" y="522501"/>
                 </a:moveTo>
                 <a:lnTo>
-                  <a:pt x="278667" y="435418"/>
-                </a:lnTo>
-                <a:lnTo>
-                  <a:pt x="278667" y="0"/>
-                </a:lnTo>
-                <a:lnTo>
-                  <a:pt x="0" y="174167"/>
+                  <a:pt x="0" y="348334"/>
+                </a:lnTo>
+                <a:lnTo>
+                  <a:pt x="0" y="0"/>
+                </a:lnTo>
+                <a:lnTo>
+                  <a:pt x="274313" y="174167"/>
                 </a:lnTo>
                 <a:close/>
               </a:path>
             </a:pathLst>
           </a:custGeom>
           <a:solidFill>
-            <a:srgbClr val="63A5B5"/>
+            <a:srgbClr val="CA9B51"/>
           </a:solidFill>
           <a:ln w="9525">
             <a:solidFill>
@@ -3393,77 +3664,74 @@
       </p:sp>
       <p:sp>
         <p:nvSpPr>
-          <p:cNvPr id="7" name="Bottom-emitting OLED / Transparent electrode label"/>
-          <p:cNvSpPr txBox="1"/>
+          <p:cNvPr id="12" name="Bottom-emitting OLED / HTL (200 nm) right"/>
+          <p:cNvSpPr/>
           <p:nvPr/>
         </p:nvSpPr>
         <p:spPr>
           <a:xfrm>
-            <a:off x="4336760" y="3478203"/>
-            <a:ext cx="3518175" cy="328305"/>
-          </a:xfrm>
-          <a:prstGeom prst="rect">
+            <a:off x="7924602" y="2997937"/>
+            <a:ext cx="274313" cy="522501"/>
+          </a:xfrm>
+          <a:custGeom>
             <a:avLst/>
-          </a:prstGeom>
-          <a:noFill/>
-        </p:spPr>
-        <p:txBody>
-          <a:bodyPr wrap="square" anchor="ctr" lIns="0" rIns="0" tIns="0" bIns="0">
-            <a:noAutofit/>
-          </a:bodyPr>
+            <a:gdLst/>
+            <a:ahLst/>
+            <a:cxnLst/>
+            <a:rect l="l" t="t" r="r" b="b"/>
+            <a:pathLst>
+              <a:path w="274313" h="522501">
+                <a:moveTo>
+                  <a:pt x="0" y="522501"/>
+                </a:moveTo>
+                <a:lnTo>
+                  <a:pt x="274313" y="348334"/>
+                </a:lnTo>
+                <a:lnTo>
+                  <a:pt x="274313" y="0"/>
+                </a:lnTo>
+                <a:lnTo>
+                  <a:pt x="0" y="174167"/>
+                </a:lnTo>
+                <a:close/>
+              </a:path>
+            </a:pathLst>
+          </a:custGeom>
+          <a:solidFill>
+            <a:srgbClr val="CA9B51"/>
+          </a:solidFill>
+          <a:ln w="9525">
+            <a:solidFill>
+              <a:srgbClr val="5D666F"/>
+            </a:solidFill>
+          </a:ln>
+          <a:effectLst/>
+        </p:spPr>
+        <p:style>
+          <a:lnRef idx="1">
+            <a:schemeClr val="accent1"/>
+          </a:lnRef>
+          <a:fillRef idx="3">
+            <a:schemeClr val="accent1"/>
+          </a:fillRef>
+          <a:effectRef idx="2">
+            <a:schemeClr val="accent1"/>
+          </a:effectRef>
+          <a:fontRef idx="minor">
+            <a:schemeClr val="lt1"/>
+          </a:fontRef>
+        </p:style>
+        <p:txBody>
+          <a:bodyPr rtlCol="0" anchor="ctr"/>
           <a:lstStyle/>
           <a:p>
             <a:pPr algn="ctr"/>
-            <a:r>
-              <a:rPr sz="994" b="0">
-                <a:solidFill>
-                  <a:srgbClr val="1B2026"/>
-                </a:solidFill>
-                <a:latin typeface="Arial"/>
-              </a:rPr>
-              <a:t>Transparent electrode</a:t>
-            </a:r>
-          </a:p>
-        </p:txBody>
-      </p:sp>
-      <p:sp>
-        <p:nvSpPr>
-          <p:cNvPr id="8" name="Bottom-emitting OLED / Transparent electrode label note"/>
-          <p:cNvSpPr txBox="1"/>
-          <p:nvPr/>
-        </p:nvSpPr>
-        <p:spPr>
-          <a:xfrm>
-            <a:off x="4336760" y="3703749"/>
-            <a:ext cx="3518175" cy="260380"/>
-          </a:xfrm>
-          <a:prstGeom prst="rect">
-            <a:avLst/>
-          </a:prstGeom>
-          <a:noFill/>
-        </p:spPr>
-        <p:txBody>
-          <a:bodyPr wrap="square" anchor="ctr" lIns="0" rIns="0" tIns="0" bIns="0">
-            <a:noAutofit/>
-          </a:bodyPr>
-          <a:lstStyle/>
-          <a:p>
-            <a:pPr algn="ctr"/>
-            <a:r>
-              <a:rPr sz="788" b="0">
-                <a:solidFill>
-                  <a:srgbClr val="D62828"/>
-                </a:solidFill>
-                <a:latin typeface="Arial"/>
-              </a:rPr>
-              <a:t>ITO 50 nm   or   Ag 10 nm</a:t>
-            </a:r>
-          </a:p>
-        </p:txBody>
-      </p:sp>
-      <p:sp>
-        <p:nvSpPr>
-          <p:cNvPr id="9" name="Bottom-emitting OLED / HTL (200 nm) front"/>
+          </a:p>
+        </p:txBody>
+      </p:sp>
+      <p:sp>
+        <p:nvSpPr>
+          <p:cNvPr id="13" name="Bottom-emitting OLED / HTL (200 nm) front"/>
           <p:cNvSpPr/>
           <p:nvPr/>
         </p:nvSpPr>
@@ -3530,14 +3798,49 @@
       </p:sp>
       <p:sp>
         <p:nvSpPr>
-          <p:cNvPr id="10" name="Bottom-emitting OLED / HTL (200 nm) side"/>
+          <p:cNvPr id="14" name="Bottom-emitting OLED / HTL (200 nm) label"/>
+          <p:cNvSpPr txBox="1"/>
+          <p:nvPr/>
+        </p:nvSpPr>
+        <p:spPr>
+          <a:xfrm>
+            <a:off x="4336760" y="3182119"/>
+            <a:ext cx="3518175" cy="328305"/>
+          </a:xfrm>
+          <a:prstGeom prst="rect">
+            <a:avLst/>
+          </a:prstGeom>
+          <a:noFill/>
+        </p:spPr>
+        <p:txBody>
+          <a:bodyPr wrap="square" anchor="ctr" lIns="0" rIns="0" tIns="0" bIns="0">
+            <a:noAutofit/>
+          </a:bodyPr>
+          <a:lstStyle/>
+          <a:p>
+            <a:pPr algn="ctr"/>
+            <a:r>
+              <a:rPr sz="994" b="0">
+                <a:solidFill>
+                  <a:srgbClr val="1B2026"/>
+                </a:solidFill>
+                <a:latin typeface="Arial"/>
+              </a:rPr>
+              <a:t>HTL (200 nm)</a:t>
+            </a:r>
+          </a:p>
+        </p:txBody>
+      </p:sp>
+      <p:sp>
+        <p:nvSpPr>
+          <p:cNvPr id="15" name="Bottom-emitting OLED / EML (20 nm) left"/>
           <p:cNvSpPr/>
           <p:nvPr/>
         </p:nvSpPr>
         <p:spPr>
           <a:xfrm>
-            <a:off x="7924602" y="2997937"/>
-            <a:ext cx="278667" cy="522501"/>
+            <a:off x="3992780" y="2719270"/>
+            <a:ext cx="274313" cy="452834"/>
           </a:xfrm>
           <a:custGeom>
             <a:avLst/>
@@ -3546,25 +3849,25 @@
             <a:cxnLst/>
             <a:rect l="l" t="t" r="r" b="b"/>
             <a:pathLst>
-              <a:path w="278667" h="522501">
+              <a:path w="274313" h="452834">
                 <a:moveTo>
-                  <a:pt x="0" y="522501"/>
+                  <a:pt x="274313" y="452834"/>
                 </a:moveTo>
                 <a:lnTo>
-                  <a:pt x="278667" y="348334"/>
-                </a:lnTo>
-                <a:lnTo>
-                  <a:pt x="278667" y="0"/>
-                </a:lnTo>
-                <a:lnTo>
-                  <a:pt x="0" y="174167"/>
+                  <a:pt x="0" y="278667"/>
+                </a:lnTo>
+                <a:lnTo>
+                  <a:pt x="0" y="0"/>
+                </a:lnTo>
+                <a:lnTo>
+                  <a:pt x="274313" y="174167"/>
                 </a:lnTo>
                 <a:close/>
               </a:path>
             </a:pathLst>
           </a:custGeom>
           <a:solidFill>
-            <a:srgbClr val="BB904B"/>
+            <a:srgbClr val="963131"/>
           </a:solidFill>
           <a:ln w="9525">
             <a:solidFill>
@@ -3597,42 +3900,74 @@
       </p:sp>
       <p:sp>
         <p:nvSpPr>
-          <p:cNvPr id="11" name="Bottom-emitting OLED / HTL (200 nm) label"/>
-          <p:cNvSpPr txBox="1"/>
+          <p:cNvPr id="16" name="Bottom-emitting OLED / EML (20 nm) right"/>
+          <p:cNvSpPr/>
           <p:nvPr/>
         </p:nvSpPr>
         <p:spPr>
           <a:xfrm>
-            <a:off x="4336760" y="3182119"/>
-            <a:ext cx="3518175" cy="328305"/>
-          </a:xfrm>
-          <a:prstGeom prst="rect">
+            <a:off x="7924602" y="2719270"/>
+            <a:ext cx="274313" cy="452834"/>
+          </a:xfrm>
+          <a:custGeom>
             <a:avLst/>
-          </a:prstGeom>
-          <a:noFill/>
-        </p:spPr>
-        <p:txBody>
-          <a:bodyPr wrap="square" anchor="ctr" lIns="0" rIns="0" tIns="0" bIns="0">
-            <a:noAutofit/>
-          </a:bodyPr>
+            <a:gdLst/>
+            <a:ahLst/>
+            <a:cxnLst/>
+            <a:rect l="l" t="t" r="r" b="b"/>
+            <a:pathLst>
+              <a:path w="274313" h="452834">
+                <a:moveTo>
+                  <a:pt x="0" y="452834"/>
+                </a:moveTo>
+                <a:lnTo>
+                  <a:pt x="274313" y="278667"/>
+                </a:lnTo>
+                <a:lnTo>
+                  <a:pt x="274313" y="0"/>
+                </a:lnTo>
+                <a:lnTo>
+                  <a:pt x="0" y="174167"/>
+                </a:lnTo>
+                <a:close/>
+              </a:path>
+            </a:pathLst>
+          </a:custGeom>
+          <a:solidFill>
+            <a:srgbClr val="963131"/>
+          </a:solidFill>
+          <a:ln w="9525">
+            <a:solidFill>
+              <a:srgbClr val="5D666F"/>
+            </a:solidFill>
+          </a:ln>
+          <a:effectLst/>
+        </p:spPr>
+        <p:style>
+          <a:lnRef idx="1">
+            <a:schemeClr val="accent1"/>
+          </a:lnRef>
+          <a:fillRef idx="3">
+            <a:schemeClr val="accent1"/>
+          </a:fillRef>
+          <a:effectRef idx="2">
+            <a:schemeClr val="accent1"/>
+          </a:effectRef>
+          <a:fontRef idx="minor">
+            <a:schemeClr val="lt1"/>
+          </a:fontRef>
+        </p:style>
+        <p:txBody>
+          <a:bodyPr rtlCol="0" anchor="ctr"/>
           <a:lstStyle/>
           <a:p>
             <a:pPr algn="ctr"/>
-            <a:r>
-              <a:rPr sz="994" b="0">
-                <a:solidFill>
-                  <a:srgbClr val="1B2026"/>
-                </a:solidFill>
-                <a:latin typeface="Arial"/>
-              </a:rPr>
-              <a:t>HTL (200 nm)</a:t>
-            </a:r>
-          </a:p>
-        </p:txBody>
-      </p:sp>
-      <p:sp>
-        <p:nvSpPr>
-          <p:cNvPr id="12" name="Bottom-emitting OLED / EML (20 nm) front"/>
+          </a:p>
+        </p:txBody>
+      </p:sp>
+      <p:sp>
+        <p:nvSpPr>
+          <p:cNvPr id="17" name="Bottom-emitting OLED / EML (20 nm) front"/>
           <p:cNvSpPr/>
           <p:nvPr/>
         </p:nvSpPr>
@@ -3699,14 +4034,49 @@
       </p:sp>
       <p:sp>
         <p:nvSpPr>
-          <p:cNvPr id="13" name="Bottom-emitting OLED / EML (20 nm) side"/>
+          <p:cNvPr id="18" name="Bottom-emitting OLED / EML (20 nm) label"/>
+          <p:cNvSpPr txBox="1"/>
+          <p:nvPr/>
+        </p:nvSpPr>
+        <p:spPr>
+          <a:xfrm>
+            <a:off x="4336760" y="2868618"/>
+            <a:ext cx="3518175" cy="328305"/>
+          </a:xfrm>
+          <a:prstGeom prst="rect">
+            <a:avLst/>
+          </a:prstGeom>
+          <a:noFill/>
+        </p:spPr>
+        <p:txBody>
+          <a:bodyPr wrap="square" anchor="ctr" lIns="0" rIns="0" tIns="0" bIns="0">
+            <a:noAutofit/>
+          </a:bodyPr>
+          <a:lstStyle/>
+          <a:p>
+            <a:pPr algn="ctr"/>
+            <a:r>
+              <a:rPr sz="994" b="0">
+                <a:solidFill>
+                  <a:srgbClr val="F2F5F8"/>
+                </a:solidFill>
+                <a:latin typeface="Arial"/>
+              </a:rPr>
+              <a:t>EML (20 nm)</a:t>
+            </a:r>
+          </a:p>
+        </p:txBody>
+      </p:sp>
+      <p:sp>
+        <p:nvSpPr>
+          <p:cNvPr id="19" name="Bottom-emitting OLED / ETL (200 nm) left"/>
           <p:cNvSpPr/>
           <p:nvPr/>
         </p:nvSpPr>
         <p:spPr>
           <a:xfrm>
-            <a:off x="7924602" y="2719270"/>
-            <a:ext cx="278667" cy="452834"/>
+            <a:off x="3992780" y="2370936"/>
+            <a:ext cx="274313" cy="522501"/>
           </a:xfrm>
           <a:custGeom>
             <a:avLst/>
@@ -3715,25 +4085,25 @@
             <a:cxnLst/>
             <a:rect l="l" t="t" r="r" b="b"/>
             <a:pathLst>
-              <a:path w="278667" h="452834">
+              <a:path w="274313" h="522501">
                 <a:moveTo>
-                  <a:pt x="0" y="452834"/>
+                  <a:pt x="274313" y="522501"/>
                 </a:moveTo>
                 <a:lnTo>
-                  <a:pt x="278667" y="278667"/>
-                </a:lnTo>
-                <a:lnTo>
-                  <a:pt x="278667" y="0"/>
-                </a:lnTo>
-                <a:lnTo>
-                  <a:pt x="0" y="174167"/>
+                  <a:pt x="0" y="348334"/>
+                </a:lnTo>
+                <a:lnTo>
+                  <a:pt x="0" y="0"/>
+                </a:lnTo>
+                <a:lnTo>
+                  <a:pt x="274313" y="174167"/>
                 </a:lnTo>
                 <a:close/>
               </a:path>
             </a:pathLst>
           </a:custGeom>
           <a:solidFill>
-            <a:srgbClr val="8B2D2D"/>
+            <a:srgbClr val="6B81B7"/>
           </a:solidFill>
           <a:ln w="9525">
             <a:solidFill>
@@ -3766,42 +4136,74 @@
       </p:sp>
       <p:sp>
         <p:nvSpPr>
-          <p:cNvPr id="14" name="Bottom-emitting OLED / EML (20 nm) label"/>
-          <p:cNvSpPr txBox="1"/>
+          <p:cNvPr id="20" name="Bottom-emitting OLED / ETL (200 nm) right"/>
+          <p:cNvSpPr/>
           <p:nvPr/>
         </p:nvSpPr>
         <p:spPr>
           <a:xfrm>
-            <a:off x="4336760" y="2868618"/>
-            <a:ext cx="3518175" cy="328305"/>
-          </a:xfrm>
-          <a:prstGeom prst="rect">
+            <a:off x="7924602" y="2370936"/>
+            <a:ext cx="274313" cy="522501"/>
+          </a:xfrm>
+          <a:custGeom>
             <a:avLst/>
-          </a:prstGeom>
-          <a:noFill/>
-        </p:spPr>
-        <p:txBody>
-          <a:bodyPr wrap="square" anchor="ctr" lIns="0" rIns="0" tIns="0" bIns="0">
-            <a:noAutofit/>
-          </a:bodyPr>
+            <a:gdLst/>
+            <a:ahLst/>
+            <a:cxnLst/>
+            <a:rect l="l" t="t" r="r" b="b"/>
+            <a:pathLst>
+              <a:path w="274313" h="522501">
+                <a:moveTo>
+                  <a:pt x="0" y="522501"/>
+                </a:moveTo>
+                <a:lnTo>
+                  <a:pt x="274313" y="348334"/>
+                </a:lnTo>
+                <a:lnTo>
+                  <a:pt x="274313" y="0"/>
+                </a:lnTo>
+                <a:lnTo>
+                  <a:pt x="0" y="174167"/>
+                </a:lnTo>
+                <a:close/>
+              </a:path>
+            </a:pathLst>
+          </a:custGeom>
+          <a:solidFill>
+            <a:srgbClr val="6B81B7"/>
+          </a:solidFill>
+          <a:ln w="9525">
+            <a:solidFill>
+              <a:srgbClr val="5D666F"/>
+            </a:solidFill>
+          </a:ln>
+          <a:effectLst/>
+        </p:spPr>
+        <p:style>
+          <a:lnRef idx="1">
+            <a:schemeClr val="accent1"/>
+          </a:lnRef>
+          <a:fillRef idx="3">
+            <a:schemeClr val="accent1"/>
+          </a:fillRef>
+          <a:effectRef idx="2">
+            <a:schemeClr val="accent1"/>
+          </a:effectRef>
+          <a:fontRef idx="minor">
+            <a:schemeClr val="lt1"/>
+          </a:fontRef>
+        </p:style>
+        <p:txBody>
+          <a:bodyPr rtlCol="0" anchor="ctr"/>
           <a:lstStyle/>
           <a:p>
             <a:pPr algn="ctr"/>
-            <a:r>
-              <a:rPr sz="994" b="0">
-                <a:solidFill>
-                  <a:srgbClr val="F2F5F8"/>
-                </a:solidFill>
-                <a:latin typeface="Arial"/>
-              </a:rPr>
-              <a:t>EML (20 nm)</a:t>
-            </a:r>
-          </a:p>
-        </p:txBody>
-      </p:sp>
-      <p:sp>
-        <p:nvSpPr>
-          <p:cNvPr id="15" name="Bottom-emitting OLED / ETL (200 nm) front"/>
+          </a:p>
+        </p:txBody>
+      </p:sp>
+      <p:sp>
+        <p:nvSpPr>
+          <p:cNvPr id="21" name="Bottom-emitting OLED / ETL (200 nm) front"/>
           <p:cNvSpPr/>
           <p:nvPr/>
         </p:nvSpPr>
@@ -3868,14 +4270,49 @@
       </p:sp>
       <p:sp>
         <p:nvSpPr>
-          <p:cNvPr id="16" name="Bottom-emitting OLED / ETL (200 nm) side"/>
+          <p:cNvPr id="22" name="Bottom-emitting OLED / ETL (200 nm) label"/>
+          <p:cNvSpPr txBox="1"/>
+          <p:nvPr/>
+        </p:nvSpPr>
+        <p:spPr>
+          <a:xfrm>
+            <a:off x="4336760" y="2555117"/>
+            <a:ext cx="3518175" cy="328305"/>
+          </a:xfrm>
+          <a:prstGeom prst="rect">
+            <a:avLst/>
+          </a:prstGeom>
+          <a:noFill/>
+        </p:spPr>
+        <p:txBody>
+          <a:bodyPr wrap="square" anchor="ctr" lIns="0" rIns="0" tIns="0" bIns="0">
+            <a:noAutofit/>
+          </a:bodyPr>
+          <a:lstStyle/>
+          <a:p>
+            <a:pPr algn="ctr"/>
+            <a:r>
+              <a:rPr sz="994" b="0">
+                <a:solidFill>
+                  <a:srgbClr val="1B2026"/>
+                </a:solidFill>
+                <a:latin typeface="Arial"/>
+              </a:rPr>
+              <a:t>ETL (200 nm)</a:t>
+            </a:r>
+          </a:p>
+        </p:txBody>
+      </p:sp>
+      <p:sp>
+        <p:nvSpPr>
+          <p:cNvPr id="23" name="Bottom-emitting OLED / Ag (100 nm) left"/>
           <p:cNvSpPr/>
           <p:nvPr/>
         </p:nvSpPr>
         <p:spPr>
           <a:xfrm>
-            <a:off x="7924602" y="2370936"/>
-            <a:ext cx="278667" cy="522501"/>
+            <a:off x="3992780" y="2092268"/>
+            <a:ext cx="274313" cy="452835"/>
           </a:xfrm>
           <a:custGeom>
             <a:avLst/>
@@ -3884,25 +4321,25 @@
             <a:cxnLst/>
             <a:rect l="l" t="t" r="r" b="b"/>
             <a:pathLst>
-              <a:path w="278667" h="522501">
+              <a:path w="274313" h="452835">
                 <a:moveTo>
-                  <a:pt x="0" y="522501"/>
+                  <a:pt x="274313" y="452835"/>
                 </a:moveTo>
                 <a:lnTo>
-                  <a:pt x="278667" y="348334"/>
-                </a:lnTo>
-                <a:lnTo>
-                  <a:pt x="278667" y="0"/>
-                </a:lnTo>
-                <a:lnTo>
-                  <a:pt x="0" y="174167"/>
+                  <a:pt x="0" y="278668"/>
+                </a:lnTo>
+                <a:lnTo>
+                  <a:pt x="0" y="0"/>
+                </a:lnTo>
+                <a:lnTo>
+                  <a:pt x="274313" y="174167"/>
                 </a:lnTo>
                 <a:close/>
               </a:path>
             </a:pathLst>
           </a:custGeom>
           <a:solidFill>
-            <a:srgbClr val="6378AA"/>
+            <a:srgbClr val="A9ADB1"/>
           </a:solidFill>
           <a:ln w="9525">
             <a:solidFill>
@@ -3935,42 +4372,141 @@
       </p:sp>
       <p:sp>
         <p:nvSpPr>
-          <p:cNvPr id="17" name="Bottom-emitting OLED / ETL (200 nm) label"/>
-          <p:cNvSpPr txBox="1"/>
+          <p:cNvPr id="24" name="Bottom-emitting OLED / Ag (100 nm) right"/>
+          <p:cNvSpPr/>
           <p:nvPr/>
         </p:nvSpPr>
         <p:spPr>
           <a:xfrm>
-            <a:off x="4336760" y="2555117"/>
-            <a:ext cx="3518175" cy="328305"/>
-          </a:xfrm>
-          <a:prstGeom prst="rect">
+            <a:off x="7924602" y="2092268"/>
+            <a:ext cx="274313" cy="452835"/>
+          </a:xfrm>
+          <a:custGeom>
             <a:avLst/>
-          </a:prstGeom>
-          <a:noFill/>
-        </p:spPr>
-        <p:txBody>
-          <a:bodyPr wrap="square" anchor="ctr" lIns="0" rIns="0" tIns="0" bIns="0">
-            <a:noAutofit/>
-          </a:bodyPr>
+            <a:gdLst/>
+            <a:ahLst/>
+            <a:cxnLst/>
+            <a:rect l="l" t="t" r="r" b="b"/>
+            <a:pathLst>
+              <a:path w="274313" h="452835">
+                <a:moveTo>
+                  <a:pt x="0" y="452835"/>
+                </a:moveTo>
+                <a:lnTo>
+                  <a:pt x="274313" y="278668"/>
+                </a:lnTo>
+                <a:lnTo>
+                  <a:pt x="274313" y="0"/>
+                </a:lnTo>
+                <a:lnTo>
+                  <a:pt x="0" y="174167"/>
+                </a:lnTo>
+                <a:close/>
+              </a:path>
+            </a:pathLst>
+          </a:custGeom>
+          <a:solidFill>
+            <a:srgbClr val="A9ADB1"/>
+          </a:solidFill>
+          <a:ln w="9525">
+            <a:solidFill>
+              <a:srgbClr val="5D666F"/>
+            </a:solidFill>
+          </a:ln>
+          <a:effectLst/>
+        </p:spPr>
+        <p:style>
+          <a:lnRef idx="1">
+            <a:schemeClr val="accent1"/>
+          </a:lnRef>
+          <a:fillRef idx="3">
+            <a:schemeClr val="accent1"/>
+          </a:fillRef>
+          <a:effectRef idx="2">
+            <a:schemeClr val="accent1"/>
+          </a:effectRef>
+          <a:fontRef idx="minor">
+            <a:schemeClr val="lt1"/>
+          </a:fontRef>
+        </p:style>
+        <p:txBody>
+          <a:bodyPr rtlCol="0" anchor="ctr"/>
           <a:lstStyle/>
           <a:p>
             <a:pPr algn="ctr"/>
-            <a:r>
-              <a:rPr sz="994" b="0">
-                <a:solidFill>
-                  <a:srgbClr val="1B2026"/>
-                </a:solidFill>
-                <a:latin typeface="Arial"/>
-              </a:rPr>
-              <a:t>ETL (200 nm)</a:t>
-            </a:r>
-          </a:p>
-        </p:txBody>
-      </p:sp>
-      <p:sp>
-        <p:nvSpPr>
-          <p:cNvPr id="18" name="Bottom-emitting OLED / Ag (100 nm) front"/>
+          </a:p>
+        </p:txBody>
+      </p:sp>
+      <p:sp>
+        <p:nvSpPr>
+          <p:cNvPr id="25" name="Bottom-emitting OLED / Ag (100 nm) top"/>
+          <p:cNvSpPr/>
+          <p:nvPr/>
+        </p:nvSpPr>
+        <p:spPr>
+          <a:xfrm>
+            <a:off x="3992780" y="2092268"/>
+            <a:ext cx="4206135" cy="174167"/>
+          </a:xfrm>
+          <a:custGeom>
+            <a:avLst/>
+            <a:gdLst/>
+            <a:ahLst/>
+            <a:cxnLst/>
+            <a:rect l="l" t="t" r="r" b="b"/>
+            <a:pathLst>
+              <a:path w="4206135" h="174167">
+                <a:moveTo>
+                  <a:pt x="274313" y="174167"/>
+                </a:moveTo>
+                <a:lnTo>
+                  <a:pt x="3931822" y="174167"/>
+                </a:lnTo>
+                <a:lnTo>
+                  <a:pt x="4206135" y="0"/>
+                </a:lnTo>
+                <a:lnTo>
+                  <a:pt x="0" y="0"/>
+                </a:lnTo>
+                <a:close/>
+              </a:path>
+            </a:pathLst>
+          </a:custGeom>
+          <a:solidFill>
+            <a:srgbClr val="DDE3E8"/>
+          </a:solidFill>
+          <a:ln w="9525">
+            <a:solidFill>
+              <a:srgbClr val="5D666F"/>
+            </a:solidFill>
+          </a:ln>
+          <a:effectLst/>
+        </p:spPr>
+        <p:style>
+          <a:lnRef idx="1">
+            <a:schemeClr val="accent1"/>
+          </a:lnRef>
+          <a:fillRef idx="3">
+            <a:schemeClr val="accent1"/>
+          </a:fillRef>
+          <a:effectRef idx="2">
+            <a:schemeClr val="accent1"/>
+          </a:effectRef>
+          <a:fontRef idx="minor">
+            <a:schemeClr val="lt1"/>
+          </a:fontRef>
+        </p:style>
+        <p:txBody>
+          <a:bodyPr rtlCol="0" anchor="ctr"/>
+          <a:lstStyle/>
+          <a:p>
+            <a:pPr algn="ctr"/>
+          </a:p>
+        </p:txBody>
+      </p:sp>
+      <p:sp>
+        <p:nvSpPr>
+          <p:cNvPr id="26" name="Bottom-emitting OLED / Ag (100 nm) front"/>
           <p:cNvSpPr/>
           <p:nvPr/>
         </p:nvSpPr>
@@ -4037,141 +4573,7 @@
       </p:sp>
       <p:sp>
         <p:nvSpPr>
-          <p:cNvPr id="19" name="Bottom-emitting OLED / Ag (100 nm) side"/>
-          <p:cNvSpPr/>
-          <p:nvPr/>
-        </p:nvSpPr>
-        <p:spPr>
-          <a:xfrm>
-            <a:off x="7924602" y="2092268"/>
-            <a:ext cx="278667" cy="452835"/>
-          </a:xfrm>
-          <a:custGeom>
-            <a:avLst/>
-            <a:gdLst/>
-            <a:ahLst/>
-            <a:cxnLst/>
-            <a:rect l="l" t="t" r="r" b="b"/>
-            <a:pathLst>
-              <a:path w="278667" h="452835">
-                <a:moveTo>
-                  <a:pt x="0" y="452835"/>
-                </a:moveTo>
-                <a:lnTo>
-                  <a:pt x="278667" y="278668"/>
-                </a:lnTo>
-                <a:lnTo>
-                  <a:pt x="278667" y="0"/>
-                </a:lnTo>
-                <a:lnTo>
-                  <a:pt x="0" y="174167"/>
-                </a:lnTo>
-                <a:close/>
-              </a:path>
-            </a:pathLst>
-          </a:custGeom>
-          <a:solidFill>
-            <a:srgbClr val="9DA1A5"/>
-          </a:solidFill>
-          <a:ln w="9525">
-            <a:solidFill>
-              <a:srgbClr val="5D666F"/>
-            </a:solidFill>
-          </a:ln>
-          <a:effectLst/>
-        </p:spPr>
-        <p:style>
-          <a:lnRef idx="1">
-            <a:schemeClr val="accent1"/>
-          </a:lnRef>
-          <a:fillRef idx="3">
-            <a:schemeClr val="accent1"/>
-          </a:fillRef>
-          <a:effectRef idx="2">
-            <a:schemeClr val="accent1"/>
-          </a:effectRef>
-          <a:fontRef idx="minor">
-            <a:schemeClr val="lt1"/>
-          </a:fontRef>
-        </p:style>
-        <p:txBody>
-          <a:bodyPr rtlCol="0" anchor="ctr"/>
-          <a:lstStyle/>
-          <a:p>
-            <a:pPr algn="ctr"/>
-          </a:p>
-        </p:txBody>
-      </p:sp>
-      <p:sp>
-        <p:nvSpPr>
-          <p:cNvPr id="20" name="Bottom-emitting OLED / Ag (100 nm) top"/>
-          <p:cNvSpPr/>
-          <p:nvPr/>
-        </p:nvSpPr>
-        <p:spPr>
-          <a:xfrm>
-            <a:off x="4267093" y="2092268"/>
-            <a:ext cx="3936176" cy="174167"/>
-          </a:xfrm>
-          <a:custGeom>
-            <a:avLst/>
-            <a:gdLst/>
-            <a:ahLst/>
-            <a:cxnLst/>
-            <a:rect l="l" t="t" r="r" b="b"/>
-            <a:pathLst>
-              <a:path w="3936176" h="174167">
-                <a:moveTo>
-                  <a:pt x="0" y="174167"/>
-                </a:moveTo>
-                <a:lnTo>
-                  <a:pt x="3657509" y="174167"/>
-                </a:lnTo>
-                <a:lnTo>
-                  <a:pt x="3936176" y="0"/>
-                </a:lnTo>
-                <a:lnTo>
-                  <a:pt x="278668" y="0"/>
-                </a:lnTo>
-                <a:close/>
-              </a:path>
-            </a:pathLst>
-          </a:custGeom>
-          <a:solidFill>
-            <a:srgbClr val="DDE3E8"/>
-          </a:solidFill>
-          <a:ln w="9525">
-            <a:solidFill>
-              <a:srgbClr val="5D666F"/>
-            </a:solidFill>
-          </a:ln>
-          <a:effectLst/>
-        </p:spPr>
-        <p:style>
-          <a:lnRef idx="1">
-            <a:schemeClr val="accent1"/>
-          </a:lnRef>
-          <a:fillRef idx="3">
-            <a:schemeClr val="accent1"/>
-          </a:fillRef>
-          <a:effectRef idx="2">
-            <a:schemeClr val="accent1"/>
-          </a:effectRef>
-          <a:fontRef idx="minor">
-            <a:schemeClr val="lt1"/>
-          </a:fontRef>
-        </p:style>
-        <p:txBody>
-          <a:bodyPr rtlCol="0" anchor="ctr"/>
-          <a:lstStyle/>
-          <a:p>
-            <a:pPr algn="ctr"/>
-          </a:p>
-        </p:txBody>
-      </p:sp>
-      <p:sp>
-        <p:nvSpPr>
-          <p:cNvPr id="21" name="Bottom-emitting OLED / Ag (100 nm) label"/>
+          <p:cNvPr id="27" name="Bottom-emitting OLED / Ag (100 nm) label"/>
           <p:cNvSpPr txBox="1"/>
           <p:nvPr/>
         </p:nvSpPr>
@@ -4206,13 +4608,13 @@
       </p:sp>
       <p:sp>
         <p:nvSpPr>
-          <p:cNvPr id="22" name="Bottom-emitting OLED title"/>
+          <p:cNvPr id="28" name="Bottom-emitting OLED title"/>
           <p:cNvSpPr txBox="1"/>
           <p:nvPr/>
         </p:nvSpPr>
         <p:spPr>
           <a:xfrm>
-            <a:off x="3971009" y="1337254"/>
+            <a:off x="3831676" y="1337254"/>
             <a:ext cx="4528344" cy="430193"/>
           </a:xfrm>
           <a:prstGeom prst="rect">
@@ -4241,7 +4643,7 @@
       </p:sp>
       <p:cxnSp>
         <p:nvCxnSpPr>
-          <p:cNvPr id="23" name="bottom emission"/>
+          <p:cNvPr id="29" name="bottom emission"/>
           <p:cNvCxnSpPr/>
           <p:nvPr/>
         </p:nvCxnSpPr>
@@ -4278,7 +4680,7 @@
       </p:cxnSp>
       <p:cxnSp>
         <p:nvCxnSpPr>
-          <p:cNvPr id="24" name="bottom emission"/>
+          <p:cNvPr id="30" name="bottom emission"/>
           <p:cNvCxnSpPr/>
           <p:nvPr/>
         </p:nvCxnSpPr>
@@ -4315,7 +4717,7 @@
       </p:cxnSp>
       <p:cxnSp>
         <p:nvCxnSpPr>
-          <p:cNvPr id="25" name="bottom emission"/>
+          <p:cNvPr id="31" name="bottom emission"/>
           <p:cNvCxnSpPr/>
           <p:nvPr/>
         </p:nvCxnSpPr>
@@ -4352,7 +4754,7 @@
       </p:cxnSp>
       <p:sp>
         <p:nvSpPr>
-          <p:cNvPr id="26" name="emission label"/>
+          <p:cNvPr id="32" name="emission label"/>
           <p:cNvSpPr txBox="1"/>
           <p:nvPr/>
         </p:nvSpPr>

</xml_diff>